<commit_message>
Focus H100 slide on model inference
</commit_message>
<xml_diff>
--- a/docs/ppt/cosmos3_edge_model_insights/cosmos3_edge_model_insights.pptx
+++ b/docs/ppt/cosmos3_edge_model_insights/cosmos3_edge_model_insights.pptx
@@ -573,7 +573,7 @@
           <a:lstStyle/>
           <a:p>
             <a:r>
-              <a:t>讲解要点：RoboLab 客户端运行在 RTX 4090，观测通过 SSH 端口转发后的 WebSocket 发往 H100 上的 Cosmos3-Edge Policy Server，返回 [32,8] action 后闭环执行。报告覆盖 requests 1–5，正式稳定态只取 warmup=false 的 request 4–5，均值 377.79 ms；n=2 只能用于初步性能判断，不能给出可靠 P95/P99。4-step、guidance=3 每请求执行 4 次 conditional 和 4 次 unconditional。network_forward 的 222.635 ms 是 8 次调用的累计值，不是单次 forward；sampler 总计 231.83 ms。理论计算量 117.087 TFLOPs/request，其中 MoT joint forward 为 115.973 TFLOPs，是首要 GPU 瓶颈。稳定峰值显存为 8438.66 MiB allocated、8644 MiB reserved，request 2–5 无增长。首请求 22.00 秒来自编译和初始化，部署前必须执行 2–3 次相同 shape 的 readiness warmup。模型效果区域由用户补入素材。</a:t>
+              <a:t>讲解要点：RoboLab 客户端运行在 RTX 4090，观测通过 SSH 端口转发后的 WebSocket 发往 H100 上的 Cosmos3-Edge Policy Server，返回 [32,8] action 后闭环执行；该拓扑只解释测试环境，不进入性能口径。本页从 generator_total 开始统计纯模型推理，排除 WebSocket、SSH、build_sample 和服务包装。稳定模型推理为 312.75 ms，对应单实例串行 3.197 inference/s。4-step、guidance=3 每次推理执行 4 次 conditional 和 4 次 unconditional。network_forward 的 222.635 ms 是 8 次调用的累计值，sampler 总计 231.83 ms。理论计算量 117.087 TFLOPs/次推理，其中 MoT joint forward 为 115.973 TFLOPs，是首要 GPU 瓶颈。稳定峰值显存为 8438.66 MiB allocated、8644 MiB reserved，request 2–5 无增长。模型效果区域由用户补入素材。</a:t>
             </a:r>
           </a:p>
         </p:txBody>
@@ -20811,8 +20811,8 @@
         </p:nvSpPr>
         <p:spPr>
           <a:xfrm>
-            <a:off x="6197600" y="3441700"/>
-            <a:ext cx="5334000" cy="165100"/>
+            <a:off x="5816600" y="3441700"/>
+            <a:ext cx="5715000" cy="165100"/>
           </a:xfrm>
           <a:prstGeom prst="rect">
             <a:avLst/>
@@ -20840,7 +20840,7 @@
               </a:defRPr>
             </a:pPr>
             <a:r>
-              <a:t>稳定态 = request 4–5 均值｜父子区间嵌套，不可直接相加</a:t>
+              <a:t>纯模型推理口径｜不含 WebSocket / SSH / 服务包装</a:t>
             </a:r>
           </a:p>
         </p:txBody>
@@ -20972,7 +20972,7 @@
               </a:defRPr>
             </a:pPr>
             <a:r>
-              <a:t>377.79 ms</a:t>
+              <a:t>312.75 ms</a:t>
             </a:r>
           </a:p>
         </p:txBody>
@@ -21014,7 +21014,7 @@
               </a:defRPr>
             </a:pPr>
             <a:r>
-              <a:t>稳定端到端 · request 4–5</a:t>
+              <a:t>generator_total · 模型推理</a:t>
             </a:r>
           </a:p>
         </p:txBody>
@@ -21146,7 +21146,7 @@
               </a:defRPr>
             </a:pPr>
             <a:r>
-              <a:t>2.647 req/s</a:t>
+              <a:t>3.197 inf/s</a:t>
             </a:r>
           </a:p>
         </p:txBody>
@@ -21188,7 +21188,7 @@
               </a:defRPr>
             </a:pPr>
             <a:r>
-              <a:t>单请求串行吞吐</a:t>
+              <a:t>单实例串行推理吞吐</a:t>
             </a:r>
           </a:p>
         </p:txBody>
@@ -21362,7 +21362,7 @@
               </a:defRPr>
             </a:pPr>
             <a:r>
-              <a:t>sampler · 61.37% E2E</a:t>
+              <a:t>sampler · 74.13% 推理</a:t>
             </a:r>
           </a:p>
         </p:txBody>
@@ -21536,7 +21536,7 @@
               </a:defRPr>
             </a:pPr>
             <a:r>
-              <a:t>理论计算量 / request</a:t>
+              <a:t>理论计算量 / 次推理</a:t>
             </a:r>
           </a:p>
         </p:txBody>
@@ -21752,7 +21752,7 @@
               </a:defRPr>
             </a:pPr>
             <a:r>
-              <a:t>A｜稳定态推理时间（ms）</a:t>
+              <a:t>A｜稳定态模型推理时间（ms）</a:t>
             </a:r>
           </a:p>
         </p:txBody>
@@ -22013,7 +22013,7 @@
               </a:defRPr>
             </a:pPr>
             <a:r>
-              <a:t>占父区间 / E2E</a:t>
+              <a:t>占模型推理</a:t>
             </a:r>
           </a:p>
         </p:txBody>
@@ -22187,7 +22187,7 @@
               </a:defRPr>
             </a:pPr>
             <a:r>
-              <a:t>request_total</a:t>
+              <a:t>generator_total</a:t>
             </a:r>
           </a:p>
         </p:txBody>
@@ -22274,7 +22274,7 @@
               </a:defRPr>
             </a:pPr>
             <a:r>
-              <a:t>377.79</a:t>
+              <a:t>312.75</a:t>
             </a:r>
           </a:p>
         </p:txBody>
@@ -22361,7 +22361,7 @@
               </a:defRPr>
             </a:pPr>
             <a:r>
-              <a:t>100% E2E</a:t>
+              <a:t>100% 推理</a:t>
             </a:r>
           </a:p>
         </p:txBody>
@@ -22448,7 +22448,7 @@
               </a:defRPr>
             </a:pPr>
             <a:r>
-              <a:t>正式 request 4–5 均值</a:t>
+              <a:t>prepare + sampler 总区间</a:t>
             </a:r>
           </a:p>
         </p:txBody>
@@ -22535,7 +22535,7 @@
               </a:defRPr>
             </a:pPr>
             <a:r>
-              <a:t>generator_total</a:t>
+              <a:t>prepare_data_total</a:t>
             </a:r>
           </a:p>
         </p:txBody>
@@ -22622,7 +22622,7 @@
               </a:defRPr>
             </a:pPr>
             <a:r>
-              <a:t>312.75</a:t>
+              <a:t>75.90</a:t>
             </a:r>
           </a:p>
         </p:txBody>
@@ -22709,7 +22709,7 @@
               </a:defRPr>
             </a:pPr>
             <a:r>
-              <a:t>82.79% E2E</a:t>
+              <a:t>24.27% 推理</a:t>
             </a:r>
           </a:p>
         </p:txBody>
@@ -22796,7 +22796,7 @@
               </a:defRPr>
             </a:pPr>
             <a:r>
-              <a:t>prepare + sampler 上层区间</a:t>
+              <a:t>condition / VAE / initial pack</a:t>
             </a:r>
           </a:p>
         </p:txBody>
@@ -22883,7 +22883,7 @@
               </a:defRPr>
             </a:pPr>
             <a:r>
-              <a:t>build_sample</a:t>
+              <a:t>vae_encode</a:t>
             </a:r>
           </a:p>
         </p:txBody>
@@ -22970,7 +22970,7 @@
               </a:defRPr>
             </a:pPr>
             <a:r>
-              <a:t>61.67</a:t>
+              <a:t>9.92</a:t>
             </a:r>
           </a:p>
         </p:txBody>
@@ -23057,7 +23057,7 @@
               </a:defRPr>
             </a:pPr>
             <a:r>
-              <a:t>16.32% E2E</a:t>
+              <a:t>3.17% 推理</a:t>
             </a:r>
           </a:p>
         </p:txBody>
@@ -23144,7 +23144,7 @@
               </a:defRPr>
             </a:pPr>
             <a:r>
-              <a:t>CPU 观测预处理</a:t>
+              <a:t>视觉条件编码，非主瓶颈</a:t>
             </a:r>
           </a:p>
         </p:txBody>
@@ -23231,7 +23231,7 @@
               </a:defRPr>
             </a:pPr>
             <a:r>
-              <a:t>prepare_data_total</a:t>
+              <a:t>sampler_total</a:t>
             </a:r>
           </a:p>
         </p:txBody>
@@ -23318,7 +23318,7 @@
               </a:defRPr>
             </a:pPr>
             <a:r>
-              <a:t>75.90</a:t>
+              <a:t>231.83</a:t>
             </a:r>
           </a:p>
         </p:txBody>
@@ -23405,7 +23405,7 @@
               </a:defRPr>
             </a:pPr>
             <a:r>
-              <a:t>20.09% E2E</a:t>
+              <a:t>74.13% 推理</a:t>
             </a:r>
           </a:p>
         </p:txBody>
@@ -23492,7 +23492,7 @@
               </a:defRPr>
             </a:pPr>
             <a:r>
-              <a:t>condition / VAE / initial pack</a:t>
+              <a:t>4-step · 4C + 4U</a:t>
             </a:r>
           </a:p>
         </p:txBody>
@@ -23579,7 +23579,7 @@
               </a:defRPr>
             </a:pPr>
             <a:r>
-              <a:t>vae_encode</a:t>
+              <a:t>network_forward</a:t>
             </a:r>
           </a:p>
         </p:txBody>
@@ -23666,7 +23666,7 @@
               </a:defRPr>
             </a:pPr>
             <a:r>
-              <a:t>9.92</a:t>
+              <a:t>222.635</a:t>
             </a:r>
           </a:p>
         </p:txBody>
@@ -23753,7 +23753,7 @@
               </a:defRPr>
             </a:pPr>
             <a:r>
-              <a:t>2.63% E2E</a:t>
+              <a:t>71.19% 推理</a:t>
             </a:r>
           </a:p>
         </p:txBody>
@@ -23840,7 +23840,7 @@
               </a:defRPr>
             </a:pPr>
             <a:r>
-              <a:t>视觉条件编码，非主瓶颈</a:t>
+              <a:t>占 sampler 96.03%</a:t>
             </a:r>
           </a:p>
         </p:txBody>
@@ -23927,7 +23927,7 @@
               </a:defRPr>
             </a:pPr>
             <a:r>
-              <a:t>sampler_total</a:t>
+              <a:t>mot_joint_forward</a:t>
             </a:r>
           </a:p>
         </p:txBody>
@@ -24014,7 +24014,7 @@
               </a:defRPr>
             </a:pPr>
             <a:r>
-              <a:t>231.83</a:t>
+              <a:t>178.407</a:t>
             </a:r>
           </a:p>
         </p:txBody>
@@ -24101,7 +24101,7 @@
               </a:defRPr>
             </a:pPr>
             <a:r>
-              <a:t>61.37% E2E</a:t>
+              <a:t>57.05% 推理</a:t>
             </a:r>
           </a:p>
         </p:txBody>
@@ -24188,7 +24188,7 @@
               </a:defRPr>
             </a:pPr>
             <a:r>
-              <a:t>4-step · 8 次网络调用</a:t>
+              <a:t>占 network 80.13%</a:t>
             </a:r>
           </a:p>
         </p:txBody>
@@ -24275,7 +24275,7 @@
               </a:defRPr>
             </a:pPr>
             <a:r>
-              <a:t>network_forward</a:t>
+              <a:t>encode_vision</a:t>
             </a:r>
           </a:p>
         </p:txBody>
@@ -24362,7 +24362,7 @@
               </a:defRPr>
             </a:pPr>
             <a:r>
-              <a:t>222.635</a:t>
+              <a:t>7.478</a:t>
             </a:r>
           </a:p>
         </p:txBody>
@@ -24449,7 +24449,7 @@
               </a:defRPr>
             </a:pPr>
             <a:r>
-              <a:t>96.03% sampler</a:t>
+              <a:t>2.39% 推理</a:t>
             </a:r>
           </a:p>
         </p:txBody>
@@ -24536,7 +24536,7 @@
               </a:defRPr>
             </a:pPr>
             <a:r>
-              <a:t>8 次 forward 累计</a:t>
+              <a:t>视觉 latent 输入投影</a:t>
             </a:r>
           </a:p>
         </p:txBody>
@@ -24623,7 +24623,7 @@
               </a:defRPr>
             </a:pPr>
             <a:r>
-              <a:t>mot_joint_forward</a:t>
+              <a:t>build_attention</a:t>
             </a:r>
           </a:p>
         </p:txBody>
@@ -24710,7 +24710,7 @@
               </a:defRPr>
             </a:pPr>
             <a:r>
-              <a:t>178.407</a:t>
+              <a:t>6.399</a:t>
             </a:r>
           </a:p>
         </p:txBody>
@@ -24797,7 +24797,7 @@
               </a:defRPr>
             </a:pPr>
             <a:r>
-              <a:t>80.13% network</a:t>
+              <a:t>2.05% 推理</a:t>
             </a:r>
           </a:p>
         </p:txBody>
@@ -24884,7 +24884,7 @@
               </a:defRPr>
             </a:pPr>
             <a:r>
-              <a:t>MoT 主干，首要 GPU 瓶颈</a:t>
+              <a:t>mask / layout / 索引构造</a:t>
             </a:r>
           </a:p>
         </p:txBody>
@@ -25100,7 +25100,7 @@
               </a:defRPr>
             </a:pPr>
             <a:r>
-              <a:t>TFLOPs / 请求</a:t>
+              <a:t>TFLOPs / 次推理</a:t>
             </a:r>
           </a:p>
         </p:txBody>
@@ -25187,7 +25187,7 @@
               </a:defRPr>
             </a:pPr>
             <a:r>
-              <a:t>占请求 FLOPs</a:t>
+              <a:t>占推理 FLOPs</a:t>
             </a:r>
           </a:p>
         </p:txBody>
@@ -25361,7 +25361,7 @@
               </a:defRPr>
             </a:pPr>
             <a:r>
-              <a:t>request / generator</a:t>
+              <a:t>generator_total</a:t>
             </a:r>
           </a:p>
         </p:txBody>
@@ -25622,7 +25622,7 @@
               </a:defRPr>
             </a:pPr>
             <a:r>
-              <a:t>309.9 TF/s · E2E</a:t>
+              <a:t>374.4 TF/s · 推理总区间</a:t>
             </a:r>
           </a:p>
         </p:txBody>
@@ -28100,7 +28100,7 @@
               </a:defRPr>
             </a:pPr>
             <a:r>
-              <a:t>结论｜MoT 承担 99.05% 理论 FLOPs、占 network 80.13% 时间；CFG 使每请求执行 4C+4U。首请求 22.00 s 属编译冷启动，必须 readiness 预热。</a:t>
+              <a:t>结论｜MoT 承担 99.05% 理论 FLOPs、占模型推理 57.05% 时间；Sampler 占 74.13%，CFG 每次推理执行 4C + 4U。</a:t>
             </a:r>
           </a:p>
         </p:txBody>
@@ -28142,7 +28142,7 @@
               </a:defRPr>
             </a:pPr>
             <a:r>
-              <a:t>Source: RoboLab Edge Policy Server 推理性能分析报告 · requests 1–5 · 2026-07-27</a:t>
+              <a:t>Source: RoboLab Edge Policy Server 推理性能分析报告 · stable samples 4–5 · 2026-07-27</a:t>
             </a:r>
           </a:p>
         </p:txBody>

</xml_diff>

<commit_message>
Refine embodied innovation slide
</commit_message>
<xml_diff>
--- a/docs/ppt/cosmos3_edge_model_insights/cosmos3_edge_model_insights.pptx
+++ b/docs/ppt/cosmos3_edge_model_insights/cosmos3_edge_model_insights.pptx
@@ -503,7 +503,7 @@
           <a:lstStyle/>
           <a:p>
             <a:r>
-              <a:t>讲解要点：左侧严格按 STEP 1→4 阅读。先把服务侧预处理折叠成 video/action/prompt 三路输入；prepare_data_total 分别完成单帧前缀 VAE、文本 tokenize，并按 text→vision→action 顺序打包，同时初始化联合噪声；sampler_total 的条件与无条件分支读取同一 joint latent，CFG 合流后由 UniPC 更新这个共享状态，再回送给下一步的两条分支；默认 guidance=3、4 个 UniPC step，因此共 8 次 MoT 前向。最后拆成 action 和可选 video 两路输出。右侧参数采用 Cosmos 3 与 LingBot-VA 官方论文/模型卡口径。具身创新聚焦 action-as-transition、跨本体 SE(3) 动作表示，以及 FD/ID/Policy 联合训练。</a:t>
+              <a:t>讲解要点：左侧严格按 STEP 1→4 阅读。先把服务侧预处理折叠成 video/action/prompt 三路输入；prepare_data_total 分别完成单帧前缀 VAE、文本 tokenize，并按 text→vision→action 顺序打包，同时初始化联合噪声；sampler_total 的条件与无条件分支读取同一 joint latent，CFG 合流后由 UniPC 更新这个共享状态，再回送给下一步的两条分支；默认 guidance=3、4 个 UniPC step，因此共 8 次 MoT 前向。最后拆成 action 和可选 video 两路输出。右侧参数采用 Cosmos 3 与 LingBot-VA 官方论文/模型卡口径。具身创新按三条主线讲解：跨具身统一 Action 表示与 Domain-aware I/O Projection；FD/ID/Policy 通过 clean/noisy token 配置共享同一 MoT；Action–Video 联合预测用视觉后果约束动作生成。</a:t>
             </a:r>
           </a:p>
         </p:txBody>
@@ -14652,7 +14652,7 @@
               </a:defRPr>
             </a:pPr>
             <a:r>
-              <a:t>具身关键创新与竞品定位</a:t>
+              <a:t>具身关键创新</a:t>
             </a:r>
           </a:p>
         </p:txBody>
@@ -14666,7 +14666,7 @@
         <p:spPr>
           <a:xfrm>
             <a:off x="7823200" y="4318000"/>
-            <a:ext cx="1231900" cy="901700"/>
+            <a:ext cx="3860800" cy="596900"/>
           </a:xfrm>
           <a:prstGeom prst="roundRect">
             <a:avLst/>
@@ -14711,7 +14711,7 @@
         <p:spPr>
           <a:xfrm>
             <a:off x="7823200" y="4318000"/>
-            <a:ext cx="1231900" cy="44450"/>
+            <a:ext cx="50800" cy="596900"/>
           </a:xfrm>
           <a:prstGeom prst="roundRect">
             <a:avLst/>
@@ -14749,43 +14749,46 @@
       </p:sp>
       <p:sp>
         <p:nvSpPr>
-          <p:cNvPr id="277" name="TextBox 276"/>
-          <p:cNvSpPr txBox="1"/>
-          <p:nvPr/>
-        </p:nvSpPr>
-        <p:spPr>
-          <a:xfrm>
-            <a:off x="7912100" y="4432300"/>
-            <a:ext cx="1054100" cy="177800"/>
-          </a:xfrm>
-          <a:prstGeom prst="rect">
-            <a:avLst/>
-          </a:prstGeom>
-          <a:noFill/>
-        </p:spPr>
-        <p:txBody>
-          <a:bodyPr wrap="none" lIns="0" rIns="0" tIns="0" bIns="0" anchor="t">
-            <a:spAutoFit/>
-          </a:bodyPr>
-          <a:lstStyle/>
-          <a:p>
-            <a:pPr algn="ctr">
-              <a:lnSpc>
-                <a:spcPct val="100000"/>
-              </a:lnSpc>
-              <a:spcAft>
-                <a:spcPts val="0"/>
-              </a:spcAft>
-              <a:defRPr sz="900" b="1">
-                <a:solidFill>
-                  <a:srgbClr val="14213D"/>
-                </a:solidFill>
-                <a:latin typeface="Microsoft YaHei"/>
-              </a:defRPr>
-            </a:pPr>
-            <a:r>
-              <a:t>Action = 状态转移</a:t>
-            </a:r>
+          <p:cNvPr id="277" name="Rounded Rectangle 276"/>
+          <p:cNvSpPr/>
+          <p:nvPr/>
+        </p:nvSpPr>
+        <p:spPr>
+          <a:xfrm>
+            <a:off x="7950200" y="4508500"/>
+            <a:ext cx="254000" cy="215900"/>
+          </a:xfrm>
+          <a:prstGeom prst="roundRect">
+            <a:avLst/>
+          </a:prstGeom>
+          <a:solidFill>
+            <a:srgbClr val="1677FF"/>
+          </a:solidFill>
+          <a:ln w="6350">
+            <a:solidFill>
+              <a:srgbClr val="1677FF"/>
+            </a:solidFill>
+          </a:ln>
+        </p:spPr>
+        <p:style>
+          <a:lnRef idx="1">
+            <a:schemeClr val="accent1"/>
+          </a:lnRef>
+          <a:fillRef idx="3">
+            <a:schemeClr val="accent1"/>
+          </a:fillRef>
+          <a:effectRef idx="2">
+            <a:schemeClr val="accent1"/>
+          </a:effectRef>
+          <a:fontRef idx="minor">
+            <a:schemeClr val="lt1"/>
+          </a:fontRef>
+        </p:style>
+        <p:txBody>
+          <a:bodyPr rtlCol="0" anchor="ctr"/>
+          <a:lstStyle/>
+          <a:p>
+            <a:pPr algn="ctr"/>
           </a:p>
         </p:txBody>
       </p:sp>
@@ -14797,512 +14800,8 @@
         </p:nvSpPr>
         <p:spPr>
           <a:xfrm>
-            <a:off x="7899400" y="4648200"/>
-            <a:ext cx="1079500" cy="508000"/>
-          </a:xfrm>
-          <a:prstGeom prst="rect">
-            <a:avLst/>
-          </a:prstGeom>
-          <a:noFill/>
-        </p:spPr>
-        <p:txBody>
-          <a:bodyPr wrap="none" lIns="0" rIns="0" tIns="0" bIns="0" anchor="ctr">
-            <a:spAutoFit/>
-          </a:bodyPr>
-          <a:lstStyle/>
-          <a:p>
-            <a:pPr algn="ctr">
-              <a:lnSpc>
-                <a:spcPct val="100000"/>
-              </a:lnSpc>
-              <a:spcAft>
-                <a:spcPts val="0"/>
-              </a:spcAft>
-              <a:defRPr sz="600" b="0">
-                <a:solidFill>
-                  <a:srgbClr val="5E6B82"/>
-                </a:solidFill>
-                <a:latin typeface="Microsoft YaHei"/>
-              </a:defRPr>
-            </a:pPr>
-            <a:r>
-              <a:t>以相邻世界状态之间的</a:t>
-            </a:r>
-            <a:br/>
-            <a:r>
-              <a:t>因果 transition 表示 action</a:t>
-            </a:r>
-            <a:br/>
-            <a:r>
-              <a:t>统一视觉与控制时序</a:t>
-            </a:r>
-          </a:p>
-        </p:txBody>
-      </p:sp>
-      <p:sp>
-        <p:nvSpPr>
-          <p:cNvPr id="279" name="Rounded Rectangle 278"/>
-          <p:cNvSpPr/>
-          <p:nvPr/>
-        </p:nvSpPr>
-        <p:spPr>
-          <a:xfrm>
-            <a:off x="9131300" y="4318000"/>
-            <a:ext cx="1231900" cy="901700"/>
-          </a:xfrm>
-          <a:prstGeom prst="roundRect">
-            <a:avLst/>
-          </a:prstGeom>
-          <a:solidFill>
-            <a:srgbClr val="FFF5E4"/>
-          </a:solidFill>
-          <a:ln w="12700">
-            <a:solidFill>
-              <a:srgbClr val="E69A24"/>
-            </a:solidFill>
-          </a:ln>
-        </p:spPr>
-        <p:style>
-          <a:lnRef idx="1">
-            <a:schemeClr val="accent1"/>
-          </a:lnRef>
-          <a:fillRef idx="3">
-            <a:schemeClr val="accent1"/>
-          </a:fillRef>
-          <a:effectRef idx="2">
-            <a:schemeClr val="accent1"/>
-          </a:effectRef>
-          <a:fontRef idx="minor">
-            <a:schemeClr val="lt1"/>
-          </a:fontRef>
-        </p:style>
-        <p:txBody>
-          <a:bodyPr rtlCol="0" anchor="ctr"/>
-          <a:lstStyle/>
-          <a:p>
-            <a:pPr algn="ctr"/>
-          </a:p>
-        </p:txBody>
-      </p:sp>
-      <p:sp>
-        <p:nvSpPr>
-          <p:cNvPr id="280" name="Rounded Rectangle 279"/>
-          <p:cNvSpPr/>
-          <p:nvPr/>
-        </p:nvSpPr>
-        <p:spPr>
-          <a:xfrm>
-            <a:off x="9131300" y="4318000"/>
-            <a:ext cx="1231900" cy="44450"/>
-          </a:xfrm>
-          <a:prstGeom prst="roundRect">
-            <a:avLst/>
-          </a:prstGeom>
-          <a:solidFill>
-            <a:srgbClr val="E69A24"/>
-          </a:solidFill>
-          <a:ln w="6350">
-            <a:solidFill>
-              <a:srgbClr val="E69A24"/>
-            </a:solidFill>
-          </a:ln>
-        </p:spPr>
-        <p:style>
-          <a:lnRef idx="1">
-            <a:schemeClr val="accent1"/>
-          </a:lnRef>
-          <a:fillRef idx="3">
-            <a:schemeClr val="accent1"/>
-          </a:fillRef>
-          <a:effectRef idx="2">
-            <a:schemeClr val="accent1"/>
-          </a:effectRef>
-          <a:fontRef idx="minor">
-            <a:schemeClr val="lt1"/>
-          </a:fontRef>
-        </p:style>
-        <p:txBody>
-          <a:bodyPr rtlCol="0" anchor="ctr"/>
-          <a:lstStyle/>
-          <a:p>
-            <a:pPr algn="ctr"/>
-          </a:p>
-        </p:txBody>
-      </p:sp>
-      <p:sp>
-        <p:nvSpPr>
-          <p:cNvPr id="281" name="TextBox 280"/>
-          <p:cNvSpPr txBox="1"/>
-          <p:nvPr/>
-        </p:nvSpPr>
-        <p:spPr>
-          <a:xfrm>
-            <a:off x="9220200" y="4432300"/>
-            <a:ext cx="1054100" cy="177800"/>
-          </a:xfrm>
-          <a:prstGeom prst="rect">
-            <a:avLst/>
-          </a:prstGeom>
-          <a:noFill/>
-        </p:spPr>
-        <p:txBody>
-          <a:bodyPr wrap="none" lIns="0" rIns="0" tIns="0" bIns="0" anchor="t">
-            <a:spAutoFit/>
-          </a:bodyPr>
-          <a:lstStyle/>
-          <a:p>
-            <a:pPr algn="ctr">
-              <a:lnSpc>
-                <a:spcPct val="100000"/>
-              </a:lnSpc>
-              <a:spcAft>
-                <a:spcPts val="0"/>
-              </a:spcAft>
-              <a:defRPr sz="900" b="1">
-                <a:solidFill>
-                  <a:srgbClr val="14213D"/>
-                </a:solidFill>
-                <a:latin typeface="Microsoft YaHei"/>
-              </a:defRPr>
-            </a:pPr>
-            <a:r>
-              <a:t>跨本体几何动作</a:t>
-            </a:r>
-          </a:p>
-        </p:txBody>
-      </p:sp>
-      <p:sp>
-        <p:nvSpPr>
-          <p:cNvPr id="282" name="TextBox 281"/>
-          <p:cNvSpPr txBox="1"/>
-          <p:nvPr/>
-        </p:nvSpPr>
-        <p:spPr>
-          <a:xfrm>
-            <a:off x="9207500" y="4648200"/>
-            <a:ext cx="1079500" cy="508000"/>
-          </a:xfrm>
-          <a:prstGeom prst="rect">
-            <a:avLst/>
-          </a:prstGeom>
-          <a:noFill/>
-        </p:spPr>
-        <p:txBody>
-          <a:bodyPr wrap="none" lIns="0" rIns="0" tIns="0" bIns="0" anchor="ctr">
-            <a:spAutoFit/>
-          </a:bodyPr>
-          <a:lstStyle/>
-          <a:p>
-            <a:pPr algn="ctr">
-              <a:lnSpc>
-                <a:spcPct val="100000"/>
-              </a:lnSpc>
-              <a:spcAft>
-                <a:spcPts val="0"/>
-              </a:spcAft>
-              <a:defRPr sz="600" b="0">
-                <a:solidFill>
-                  <a:srgbClr val="5E6B82"/>
-                </a:solidFill>
-                <a:latin typeface="Microsoft YaHei"/>
-              </a:defRPr>
-            </a:pPr>
-            <a:r>
-              <a:t>ego / effector / grasp</a:t>
-            </a:r>
-            <a:br/>
-            <a:r>
-              <a:t>采用相对 SE(3)；domain-aware</a:t>
-            </a:r>
-            <a:br/>
-            <a:r>
-              <a:t>I/O 保留本体差异</a:t>
-            </a:r>
-          </a:p>
-        </p:txBody>
-      </p:sp>
-      <p:sp>
-        <p:nvSpPr>
-          <p:cNvPr id="283" name="Rounded Rectangle 282"/>
-          <p:cNvSpPr/>
-          <p:nvPr/>
-        </p:nvSpPr>
-        <p:spPr>
-          <a:xfrm>
-            <a:off x="10439400" y="4318000"/>
-            <a:ext cx="1231900" cy="901700"/>
-          </a:xfrm>
-          <a:prstGeom prst="roundRect">
-            <a:avLst/>
-          </a:prstGeom>
-          <a:solidFill>
-            <a:srgbClr val="EAF8F1"/>
-          </a:solidFill>
-          <a:ln w="12700">
-            <a:solidFill>
-              <a:srgbClr val="20A464"/>
-            </a:solidFill>
-          </a:ln>
-        </p:spPr>
-        <p:style>
-          <a:lnRef idx="1">
-            <a:schemeClr val="accent1"/>
-          </a:lnRef>
-          <a:fillRef idx="3">
-            <a:schemeClr val="accent1"/>
-          </a:fillRef>
-          <a:effectRef idx="2">
-            <a:schemeClr val="accent1"/>
-          </a:effectRef>
-          <a:fontRef idx="minor">
-            <a:schemeClr val="lt1"/>
-          </a:fontRef>
-        </p:style>
-        <p:txBody>
-          <a:bodyPr rtlCol="0" anchor="ctr"/>
-          <a:lstStyle/>
-          <a:p>
-            <a:pPr algn="ctr"/>
-          </a:p>
-        </p:txBody>
-      </p:sp>
-      <p:sp>
-        <p:nvSpPr>
-          <p:cNvPr id="284" name="Rounded Rectangle 283"/>
-          <p:cNvSpPr/>
-          <p:nvPr/>
-        </p:nvSpPr>
-        <p:spPr>
-          <a:xfrm>
-            <a:off x="10439400" y="4318000"/>
-            <a:ext cx="1231900" cy="44450"/>
-          </a:xfrm>
-          <a:prstGeom prst="roundRect">
-            <a:avLst/>
-          </a:prstGeom>
-          <a:solidFill>
-            <a:srgbClr val="20A464"/>
-          </a:solidFill>
-          <a:ln w="6350">
-            <a:solidFill>
-              <a:srgbClr val="20A464"/>
-            </a:solidFill>
-          </a:ln>
-        </p:spPr>
-        <p:style>
-          <a:lnRef idx="1">
-            <a:schemeClr val="accent1"/>
-          </a:lnRef>
-          <a:fillRef idx="3">
-            <a:schemeClr val="accent1"/>
-          </a:fillRef>
-          <a:effectRef idx="2">
-            <a:schemeClr val="accent1"/>
-          </a:effectRef>
-          <a:fontRef idx="minor">
-            <a:schemeClr val="lt1"/>
-          </a:fontRef>
-        </p:style>
-        <p:txBody>
-          <a:bodyPr rtlCol="0" anchor="ctr"/>
-          <a:lstStyle/>
-          <a:p>
-            <a:pPr algn="ctr"/>
-          </a:p>
-        </p:txBody>
-      </p:sp>
-      <p:sp>
-        <p:nvSpPr>
-          <p:cNvPr id="285" name="TextBox 284"/>
-          <p:cNvSpPr txBox="1"/>
-          <p:nvPr/>
-        </p:nvSpPr>
-        <p:spPr>
-          <a:xfrm>
-            <a:off x="10528300" y="4432300"/>
-            <a:ext cx="1054100" cy="177800"/>
-          </a:xfrm>
-          <a:prstGeom prst="rect">
-            <a:avLst/>
-          </a:prstGeom>
-          <a:noFill/>
-        </p:spPr>
-        <p:txBody>
-          <a:bodyPr wrap="none" lIns="0" rIns="0" tIns="0" bIns="0" anchor="t">
-            <a:spAutoFit/>
-          </a:bodyPr>
-          <a:lstStyle/>
-          <a:p>
-            <a:pPr algn="ctr">
-              <a:lnSpc>
-                <a:spcPct val="100000"/>
-              </a:lnSpc>
-              <a:spcAft>
-                <a:spcPts val="0"/>
-              </a:spcAft>
-              <a:defRPr sz="900" b="1">
-                <a:solidFill>
-                  <a:srgbClr val="14213D"/>
-                </a:solidFill>
-                <a:latin typeface="Microsoft YaHei"/>
-              </a:defRPr>
-            </a:pPr>
-            <a:r>
-              <a:t>FD / ID / Policy 联训</a:t>
-            </a:r>
-          </a:p>
-        </p:txBody>
-      </p:sp>
-      <p:sp>
-        <p:nvSpPr>
-          <p:cNvPr id="286" name="TextBox 285"/>
-          <p:cNvSpPr txBox="1"/>
-          <p:nvPr/>
-        </p:nvSpPr>
-        <p:spPr>
-          <a:xfrm>
-            <a:off x="10515600" y="4648200"/>
-            <a:ext cx="1079500" cy="508000"/>
-          </a:xfrm>
-          <a:prstGeom prst="rect">
-            <a:avLst/>
-          </a:prstGeom>
-          <a:noFill/>
-        </p:spPr>
-        <p:txBody>
-          <a:bodyPr wrap="none" lIns="0" rIns="0" tIns="0" bIns="0" anchor="ctr">
-            <a:spAutoFit/>
-          </a:bodyPr>
-          <a:lstStyle/>
-          <a:p>
-            <a:pPr algn="ctr">
-              <a:lnSpc>
-                <a:spcPct val="100000"/>
-              </a:lnSpc>
-              <a:spcAft>
-                <a:spcPts val="0"/>
-              </a:spcAft>
-              <a:defRPr sz="600" b="0">
-                <a:solidFill>
-                  <a:srgbClr val="5E6B82"/>
-                </a:solidFill>
-                <a:latin typeface="Microsoft YaHei"/>
-              </a:defRPr>
-            </a:pPr>
-            <a:r>
-              <a:t>前向动力学、逆动力学、策略</a:t>
-            </a:r>
-            <a:br/>
-            <a:r>
-              <a:t>共享 MoT；联合预测 future visual</a:t>
-            </a:r>
-            <a:br/>
-            <a:r>
-              <a:t>与 action diffusion</a:t>
-            </a:r>
-          </a:p>
-        </p:txBody>
-      </p:sp>
-      <p:sp>
-        <p:nvSpPr>
-          <p:cNvPr id="287" name="Rounded Rectangle 286"/>
-          <p:cNvSpPr/>
-          <p:nvPr/>
-        </p:nvSpPr>
-        <p:spPr>
-          <a:xfrm>
-            <a:off x="7823200" y="5346700"/>
-            <a:ext cx="3860800" cy="749300"/>
-          </a:xfrm>
-          <a:prstGeom prst="roundRect">
-            <a:avLst/>
-          </a:prstGeom>
-          <a:solidFill>
-            <a:srgbClr val="EDF2F8"/>
-          </a:solidFill>
-          <a:ln w="12700">
-            <a:solidFill>
-              <a:srgbClr val="AFC2D9"/>
-            </a:solidFill>
-          </a:ln>
-        </p:spPr>
-        <p:style>
-          <a:lnRef idx="1">
-            <a:schemeClr val="accent1"/>
-          </a:lnRef>
-          <a:fillRef idx="3">
-            <a:schemeClr val="accent1"/>
-          </a:fillRef>
-          <a:effectRef idx="2">
-            <a:schemeClr val="accent1"/>
-          </a:effectRef>
-          <a:fontRef idx="minor">
-            <a:schemeClr val="lt1"/>
-          </a:fontRef>
-        </p:style>
-        <p:txBody>
-          <a:bodyPr rtlCol="0" anchor="ctr"/>
-          <a:lstStyle/>
-          <a:p>
-            <a:pPr algn="ctr"/>
-          </a:p>
-        </p:txBody>
-      </p:sp>
-      <p:sp>
-        <p:nvSpPr>
-          <p:cNvPr id="288" name="Rounded Rectangle 287"/>
-          <p:cNvSpPr/>
-          <p:nvPr/>
-        </p:nvSpPr>
-        <p:spPr>
-          <a:xfrm>
-            <a:off x="7924799" y="5441950"/>
-            <a:ext cx="863600" cy="215900"/>
-          </a:xfrm>
-          <a:prstGeom prst="roundRect">
-            <a:avLst/>
-          </a:prstGeom>
-          <a:solidFill>
-            <a:srgbClr val="183B66"/>
-          </a:solidFill>
-          <a:ln w="6350">
-            <a:solidFill>
-              <a:srgbClr val="183B66"/>
-            </a:solidFill>
-          </a:ln>
-        </p:spPr>
-        <p:style>
-          <a:lnRef idx="1">
-            <a:schemeClr val="accent1"/>
-          </a:lnRef>
-          <a:fillRef idx="3">
-            <a:schemeClr val="accent1"/>
-          </a:fillRef>
-          <a:effectRef idx="2">
-            <a:schemeClr val="accent1"/>
-          </a:effectRef>
-          <a:fontRef idx="minor">
-            <a:schemeClr val="lt1"/>
-          </a:fontRef>
-        </p:style>
-        <p:txBody>
-          <a:bodyPr rtlCol="0" anchor="ctr"/>
-          <a:lstStyle/>
-          <a:p>
-            <a:pPr algn="ctr"/>
-          </a:p>
-        </p:txBody>
-      </p:sp>
-      <p:sp>
-        <p:nvSpPr>
-          <p:cNvPr id="289" name="TextBox 288"/>
-          <p:cNvSpPr txBox="1"/>
-          <p:nvPr/>
-        </p:nvSpPr>
-        <p:spPr>
-          <a:xfrm>
-            <a:off x="7924799" y="5441950"/>
-            <a:ext cx="863600" cy="215900"/>
+            <a:off x="7950200" y="4508500"/>
+            <a:ext cx="254000" cy="215900"/>
           </a:xfrm>
           <a:prstGeom prst="rect">
             <a:avLst/>
@@ -15330,21 +14829,21 @@
               </a:defRPr>
             </a:pPr>
             <a:r>
-              <a:t>vs LingBot-VA</a:t>
-            </a:r>
-          </a:p>
-        </p:txBody>
-      </p:sp>
-      <p:sp>
-        <p:nvSpPr>
-          <p:cNvPr id="290" name="TextBox 289"/>
+              <a:t>01</a:t>
+            </a:r>
+          </a:p>
+        </p:txBody>
+      </p:sp>
+      <p:sp>
+        <p:nvSpPr>
+          <p:cNvPr id="279" name="TextBox 278"/>
           <p:cNvSpPr txBox="1"/>
           <p:nvPr/>
         </p:nvSpPr>
         <p:spPr>
           <a:xfrm>
-            <a:off x="8877300" y="5397500"/>
-            <a:ext cx="2667000" cy="292100"/>
+            <a:off x="8318499" y="4400550"/>
+            <a:ext cx="1333500" cy="431800"/>
           </a:xfrm>
           <a:prstGeom prst="rect">
             <a:avLst/>
@@ -15364,29 +14863,33 @@
               <a:spcAft>
                 <a:spcPts val="0"/>
               </a:spcAft>
-              <a:defRPr sz="1000" b="1">
+              <a:defRPr sz="850" b="1">
                 <a:solidFill>
-                  <a:srgbClr val="183B66"/>
+                  <a:srgbClr val="14213D"/>
                 </a:solidFill>
                 <a:latin typeface="Microsoft YaHei"/>
               </a:defRPr>
             </a:pPr>
             <a:r>
-              <a:t>优势在“统一模型迁移闭环”</a:t>
-            </a:r>
-          </a:p>
-        </p:txBody>
-      </p:sp>
-      <p:sp>
-        <p:nvSpPr>
-          <p:cNvPr id="291" name="TextBox 290"/>
+              <a:t>跨具身统一</a:t>
+            </a:r>
+            <a:br/>
+            <a:r>
+              <a:t>Action 表示</a:t>
+            </a:r>
+          </a:p>
+        </p:txBody>
+      </p:sp>
+      <p:sp>
+        <p:nvSpPr>
+          <p:cNvPr id="280" name="TextBox 279"/>
           <p:cNvSpPr txBox="1"/>
           <p:nvPr/>
         </p:nvSpPr>
         <p:spPr>
           <a:xfrm>
-            <a:off x="7924799" y="5715000"/>
-            <a:ext cx="3581400" cy="304800"/>
+            <a:off x="9677400" y="4394200"/>
+            <a:ext cx="1866899" cy="444500"/>
           </a:xfrm>
           <a:prstGeom prst="rect">
             <a:avLst/>
@@ -15395,52 +14898,6 @@
         </p:spPr>
         <p:txBody>
           <a:bodyPr wrap="none" lIns="0" rIns="0" tIns="0" bIns="0" anchor="ctr">
-            <a:spAutoFit/>
-          </a:bodyPr>
-          <a:lstStyle/>
-          <a:p>
-            <a:pPr algn="l">
-              <a:lnSpc>
-                <a:spcPct val="100000"/>
-              </a:lnSpc>
-              <a:spcAft>
-                <a:spcPts val="0"/>
-              </a:spcAft>
-              <a:defRPr sz="750" b="0">
-                <a:solidFill>
-                  <a:srgbClr val="5E6B82"/>
-                </a:solidFill>
-                <a:latin typeface="Microsoft YaHei"/>
-              </a:defRPr>
-            </a:pPr>
-            <a:r>
-              <a:t>Edge：同模型贯通理解→生成→动作；LingBot-VA：面向实时控制的因果双流。</a:t>
-            </a:r>
-            <a:br/>
-            <a:r>
-              <a:t>结论：能力边界更统一 ≠ 已证明实时吞吐更高。</a:t>
-            </a:r>
-          </a:p>
-        </p:txBody>
-      </p:sp>
-      <p:sp>
-        <p:nvSpPr>
-          <p:cNvPr id="292" name="TextBox 291"/>
-          <p:cNvSpPr txBox="1"/>
-          <p:nvPr/>
-        </p:nvSpPr>
-        <p:spPr>
-          <a:xfrm>
-            <a:off x="355600" y="6584950"/>
-            <a:ext cx="11480800" cy="139700"/>
-          </a:xfrm>
-          <a:prstGeom prst="rect">
-            <a:avLst/>
-          </a:prstGeom>
-          <a:noFill/>
-        </p:spPr>
-        <p:txBody>
-          <a:bodyPr wrap="none" lIns="0" rIns="0" tIns="0" bIns="0" anchor="t">
             <a:spAutoFit/>
           </a:bodyPr>
           <a:lstStyle/>
@@ -15460,6 +14917,590 @@
               </a:defRPr>
             </a:pPr>
             <a:r>
+              <a:t>共享几何语义</a:t>
+            </a:r>
+            <a:br/>
+            <a:r>
+              <a:t>Domain-aware I/O Projection 适配不同动作空间</a:t>
+            </a:r>
+          </a:p>
+        </p:txBody>
+      </p:sp>
+      <p:sp>
+        <p:nvSpPr>
+          <p:cNvPr id="281" name="Rounded Rectangle 280"/>
+          <p:cNvSpPr/>
+          <p:nvPr/>
+        </p:nvSpPr>
+        <p:spPr>
+          <a:xfrm>
+            <a:off x="7823200" y="4991100"/>
+            <a:ext cx="3860800" cy="596900"/>
+          </a:xfrm>
+          <a:prstGeom prst="roundRect">
+            <a:avLst/>
+          </a:prstGeom>
+          <a:solidFill>
+            <a:srgbClr val="FFF5E4"/>
+          </a:solidFill>
+          <a:ln w="12700">
+            <a:solidFill>
+              <a:srgbClr val="E69A24"/>
+            </a:solidFill>
+          </a:ln>
+        </p:spPr>
+        <p:style>
+          <a:lnRef idx="1">
+            <a:schemeClr val="accent1"/>
+          </a:lnRef>
+          <a:fillRef idx="3">
+            <a:schemeClr val="accent1"/>
+          </a:fillRef>
+          <a:effectRef idx="2">
+            <a:schemeClr val="accent1"/>
+          </a:effectRef>
+          <a:fontRef idx="minor">
+            <a:schemeClr val="lt1"/>
+          </a:fontRef>
+        </p:style>
+        <p:txBody>
+          <a:bodyPr rtlCol="0" anchor="ctr"/>
+          <a:lstStyle/>
+          <a:p>
+            <a:pPr algn="ctr"/>
+          </a:p>
+        </p:txBody>
+      </p:sp>
+      <p:sp>
+        <p:nvSpPr>
+          <p:cNvPr id="282" name="Rounded Rectangle 281"/>
+          <p:cNvSpPr/>
+          <p:nvPr/>
+        </p:nvSpPr>
+        <p:spPr>
+          <a:xfrm>
+            <a:off x="7823200" y="4991100"/>
+            <a:ext cx="50800" cy="596900"/>
+          </a:xfrm>
+          <a:prstGeom prst="roundRect">
+            <a:avLst/>
+          </a:prstGeom>
+          <a:solidFill>
+            <a:srgbClr val="E69A24"/>
+          </a:solidFill>
+          <a:ln w="6350">
+            <a:solidFill>
+              <a:srgbClr val="E69A24"/>
+            </a:solidFill>
+          </a:ln>
+        </p:spPr>
+        <p:style>
+          <a:lnRef idx="1">
+            <a:schemeClr val="accent1"/>
+          </a:lnRef>
+          <a:fillRef idx="3">
+            <a:schemeClr val="accent1"/>
+          </a:fillRef>
+          <a:effectRef idx="2">
+            <a:schemeClr val="accent1"/>
+          </a:effectRef>
+          <a:fontRef idx="minor">
+            <a:schemeClr val="lt1"/>
+          </a:fontRef>
+        </p:style>
+        <p:txBody>
+          <a:bodyPr rtlCol="0" anchor="ctr"/>
+          <a:lstStyle/>
+          <a:p>
+            <a:pPr algn="ctr"/>
+          </a:p>
+        </p:txBody>
+      </p:sp>
+      <p:sp>
+        <p:nvSpPr>
+          <p:cNvPr id="283" name="Rounded Rectangle 282"/>
+          <p:cNvSpPr/>
+          <p:nvPr/>
+        </p:nvSpPr>
+        <p:spPr>
+          <a:xfrm>
+            <a:off x="7950200" y="5181600"/>
+            <a:ext cx="254000" cy="215900"/>
+          </a:xfrm>
+          <a:prstGeom prst="roundRect">
+            <a:avLst/>
+          </a:prstGeom>
+          <a:solidFill>
+            <a:srgbClr val="E69A24"/>
+          </a:solidFill>
+          <a:ln w="6350">
+            <a:solidFill>
+              <a:srgbClr val="E69A24"/>
+            </a:solidFill>
+          </a:ln>
+        </p:spPr>
+        <p:style>
+          <a:lnRef idx="1">
+            <a:schemeClr val="accent1"/>
+          </a:lnRef>
+          <a:fillRef idx="3">
+            <a:schemeClr val="accent1"/>
+          </a:fillRef>
+          <a:effectRef idx="2">
+            <a:schemeClr val="accent1"/>
+          </a:effectRef>
+          <a:fontRef idx="minor">
+            <a:schemeClr val="lt1"/>
+          </a:fontRef>
+        </p:style>
+        <p:txBody>
+          <a:bodyPr rtlCol="0" anchor="ctr"/>
+          <a:lstStyle/>
+          <a:p>
+            <a:pPr algn="ctr"/>
+          </a:p>
+        </p:txBody>
+      </p:sp>
+      <p:sp>
+        <p:nvSpPr>
+          <p:cNvPr id="284" name="TextBox 283"/>
+          <p:cNvSpPr txBox="1"/>
+          <p:nvPr/>
+        </p:nvSpPr>
+        <p:spPr>
+          <a:xfrm>
+            <a:off x="7950200" y="5181600"/>
+            <a:ext cx="254000" cy="215900"/>
+          </a:xfrm>
+          <a:prstGeom prst="rect">
+            <a:avLst/>
+          </a:prstGeom>
+          <a:noFill/>
+        </p:spPr>
+        <p:txBody>
+          <a:bodyPr wrap="none" lIns="0" rIns="0" tIns="0" bIns="0" anchor="ctr">
+            <a:spAutoFit/>
+          </a:bodyPr>
+          <a:lstStyle/>
+          <a:p>
+            <a:pPr algn="ctr">
+              <a:lnSpc>
+                <a:spcPct val="100000"/>
+              </a:lnSpc>
+              <a:spcAft>
+                <a:spcPts val="0"/>
+              </a:spcAft>
+              <a:defRPr sz="850" b="1">
+                <a:solidFill>
+                  <a:srgbClr val="FFFFFF"/>
+                </a:solidFill>
+                <a:latin typeface="Microsoft YaHei"/>
+              </a:defRPr>
+            </a:pPr>
+            <a:r>
+              <a:t>02</a:t>
+            </a:r>
+          </a:p>
+        </p:txBody>
+      </p:sp>
+      <p:sp>
+        <p:nvSpPr>
+          <p:cNvPr id="285" name="TextBox 284"/>
+          <p:cNvSpPr txBox="1"/>
+          <p:nvPr/>
+        </p:nvSpPr>
+        <p:spPr>
+          <a:xfrm>
+            <a:off x="8318499" y="5073650"/>
+            <a:ext cx="1333500" cy="431800"/>
+          </a:xfrm>
+          <a:prstGeom prst="rect">
+            <a:avLst/>
+          </a:prstGeom>
+          <a:noFill/>
+        </p:spPr>
+        <p:txBody>
+          <a:bodyPr wrap="none" lIns="0" rIns="0" tIns="0" bIns="0" anchor="ctr">
+            <a:spAutoFit/>
+          </a:bodyPr>
+          <a:lstStyle/>
+          <a:p>
+            <a:pPr algn="l">
+              <a:lnSpc>
+                <a:spcPct val="100000"/>
+              </a:lnSpc>
+              <a:spcAft>
+                <a:spcPts val="0"/>
+              </a:spcAft>
+              <a:defRPr sz="850" b="1">
+                <a:solidFill>
+                  <a:srgbClr val="14213D"/>
+                </a:solidFill>
+                <a:latin typeface="Microsoft YaHei"/>
+              </a:defRPr>
+            </a:pPr>
+            <a:r>
+              <a:t>FD / ID / Policy</a:t>
+            </a:r>
+            <a:br/>
+            <a:r>
+              <a:t>三模式共享</a:t>
+            </a:r>
+          </a:p>
+        </p:txBody>
+      </p:sp>
+      <p:sp>
+        <p:nvSpPr>
+          <p:cNvPr id="286" name="TextBox 285"/>
+          <p:cNvSpPr txBox="1"/>
+          <p:nvPr/>
+        </p:nvSpPr>
+        <p:spPr>
+          <a:xfrm>
+            <a:off x="9677400" y="5067300"/>
+            <a:ext cx="1866899" cy="444500"/>
+          </a:xfrm>
+          <a:prstGeom prst="rect">
+            <a:avLst/>
+          </a:prstGeom>
+          <a:noFill/>
+        </p:spPr>
+        <p:txBody>
+          <a:bodyPr wrap="none" lIns="0" rIns="0" tIns="0" bIns="0" anchor="ctr">
+            <a:spAutoFit/>
+          </a:bodyPr>
+          <a:lstStyle/>
+          <a:p>
+            <a:pPr algn="l">
+              <a:lnSpc>
+                <a:spcPct val="100000"/>
+              </a:lnSpc>
+              <a:spcAft>
+                <a:spcPts val="0"/>
+              </a:spcAft>
+              <a:defRPr sz="650" b="0">
+                <a:solidFill>
+                  <a:srgbClr val="5E6B82"/>
+                </a:solidFill>
+                <a:latin typeface="Microsoft YaHei"/>
+              </a:defRPr>
+            </a:pPr>
+            <a:r>
+              <a:t>同一 MoT 通过 clean / noisy token 配置</a:t>
+            </a:r>
+            <a:br/>
+            <a:r>
+              <a:t>学习 Forward Dynamics、Inverse Dynamics 与 Policy</a:t>
+            </a:r>
+          </a:p>
+        </p:txBody>
+      </p:sp>
+      <p:sp>
+        <p:nvSpPr>
+          <p:cNvPr id="287" name="Rounded Rectangle 286"/>
+          <p:cNvSpPr/>
+          <p:nvPr/>
+        </p:nvSpPr>
+        <p:spPr>
+          <a:xfrm>
+            <a:off x="7823200" y="5664200"/>
+            <a:ext cx="3860800" cy="596900"/>
+          </a:xfrm>
+          <a:prstGeom prst="roundRect">
+            <a:avLst/>
+          </a:prstGeom>
+          <a:solidFill>
+            <a:srgbClr val="EAF8F1"/>
+          </a:solidFill>
+          <a:ln w="12700">
+            <a:solidFill>
+              <a:srgbClr val="20A464"/>
+            </a:solidFill>
+          </a:ln>
+        </p:spPr>
+        <p:style>
+          <a:lnRef idx="1">
+            <a:schemeClr val="accent1"/>
+          </a:lnRef>
+          <a:fillRef idx="3">
+            <a:schemeClr val="accent1"/>
+          </a:fillRef>
+          <a:effectRef idx="2">
+            <a:schemeClr val="accent1"/>
+          </a:effectRef>
+          <a:fontRef idx="minor">
+            <a:schemeClr val="lt1"/>
+          </a:fontRef>
+        </p:style>
+        <p:txBody>
+          <a:bodyPr rtlCol="0" anchor="ctr"/>
+          <a:lstStyle/>
+          <a:p>
+            <a:pPr algn="ctr"/>
+          </a:p>
+        </p:txBody>
+      </p:sp>
+      <p:sp>
+        <p:nvSpPr>
+          <p:cNvPr id="288" name="Rounded Rectangle 287"/>
+          <p:cNvSpPr/>
+          <p:nvPr/>
+        </p:nvSpPr>
+        <p:spPr>
+          <a:xfrm>
+            <a:off x="7823200" y="5664200"/>
+            <a:ext cx="50800" cy="596900"/>
+          </a:xfrm>
+          <a:prstGeom prst="roundRect">
+            <a:avLst/>
+          </a:prstGeom>
+          <a:solidFill>
+            <a:srgbClr val="20A464"/>
+          </a:solidFill>
+          <a:ln w="6350">
+            <a:solidFill>
+              <a:srgbClr val="20A464"/>
+            </a:solidFill>
+          </a:ln>
+        </p:spPr>
+        <p:style>
+          <a:lnRef idx="1">
+            <a:schemeClr val="accent1"/>
+          </a:lnRef>
+          <a:fillRef idx="3">
+            <a:schemeClr val="accent1"/>
+          </a:fillRef>
+          <a:effectRef idx="2">
+            <a:schemeClr val="accent1"/>
+          </a:effectRef>
+          <a:fontRef idx="minor">
+            <a:schemeClr val="lt1"/>
+          </a:fontRef>
+        </p:style>
+        <p:txBody>
+          <a:bodyPr rtlCol="0" anchor="ctr"/>
+          <a:lstStyle/>
+          <a:p>
+            <a:pPr algn="ctr"/>
+          </a:p>
+        </p:txBody>
+      </p:sp>
+      <p:sp>
+        <p:nvSpPr>
+          <p:cNvPr id="289" name="Rounded Rectangle 288"/>
+          <p:cNvSpPr/>
+          <p:nvPr/>
+        </p:nvSpPr>
+        <p:spPr>
+          <a:xfrm>
+            <a:off x="7950200" y="5854700"/>
+            <a:ext cx="254000" cy="215900"/>
+          </a:xfrm>
+          <a:prstGeom prst="roundRect">
+            <a:avLst/>
+          </a:prstGeom>
+          <a:solidFill>
+            <a:srgbClr val="20A464"/>
+          </a:solidFill>
+          <a:ln w="6350">
+            <a:solidFill>
+              <a:srgbClr val="20A464"/>
+            </a:solidFill>
+          </a:ln>
+        </p:spPr>
+        <p:style>
+          <a:lnRef idx="1">
+            <a:schemeClr val="accent1"/>
+          </a:lnRef>
+          <a:fillRef idx="3">
+            <a:schemeClr val="accent1"/>
+          </a:fillRef>
+          <a:effectRef idx="2">
+            <a:schemeClr val="accent1"/>
+          </a:effectRef>
+          <a:fontRef idx="minor">
+            <a:schemeClr val="lt1"/>
+          </a:fontRef>
+        </p:style>
+        <p:txBody>
+          <a:bodyPr rtlCol="0" anchor="ctr"/>
+          <a:lstStyle/>
+          <a:p>
+            <a:pPr algn="ctr"/>
+          </a:p>
+        </p:txBody>
+      </p:sp>
+      <p:sp>
+        <p:nvSpPr>
+          <p:cNvPr id="290" name="TextBox 289"/>
+          <p:cNvSpPr txBox="1"/>
+          <p:nvPr/>
+        </p:nvSpPr>
+        <p:spPr>
+          <a:xfrm>
+            <a:off x="7950200" y="5854700"/>
+            <a:ext cx="254000" cy="215900"/>
+          </a:xfrm>
+          <a:prstGeom prst="rect">
+            <a:avLst/>
+          </a:prstGeom>
+          <a:noFill/>
+        </p:spPr>
+        <p:txBody>
+          <a:bodyPr wrap="none" lIns="0" rIns="0" tIns="0" bIns="0" anchor="ctr">
+            <a:spAutoFit/>
+          </a:bodyPr>
+          <a:lstStyle/>
+          <a:p>
+            <a:pPr algn="ctr">
+              <a:lnSpc>
+                <a:spcPct val="100000"/>
+              </a:lnSpc>
+              <a:spcAft>
+                <a:spcPts val="0"/>
+              </a:spcAft>
+              <a:defRPr sz="850" b="1">
+                <a:solidFill>
+                  <a:srgbClr val="FFFFFF"/>
+                </a:solidFill>
+                <a:latin typeface="Microsoft YaHei"/>
+              </a:defRPr>
+            </a:pPr>
+            <a:r>
+              <a:t>03</a:t>
+            </a:r>
+          </a:p>
+        </p:txBody>
+      </p:sp>
+      <p:sp>
+        <p:nvSpPr>
+          <p:cNvPr id="291" name="TextBox 290"/>
+          <p:cNvSpPr txBox="1"/>
+          <p:nvPr/>
+        </p:nvSpPr>
+        <p:spPr>
+          <a:xfrm>
+            <a:off x="8318499" y="5746750"/>
+            <a:ext cx="1333500" cy="431800"/>
+          </a:xfrm>
+          <a:prstGeom prst="rect">
+            <a:avLst/>
+          </a:prstGeom>
+          <a:noFill/>
+        </p:spPr>
+        <p:txBody>
+          <a:bodyPr wrap="none" lIns="0" rIns="0" tIns="0" bIns="0" anchor="ctr">
+            <a:spAutoFit/>
+          </a:bodyPr>
+          <a:lstStyle/>
+          <a:p>
+            <a:pPr algn="l">
+              <a:lnSpc>
+                <a:spcPct val="100000"/>
+              </a:lnSpc>
+              <a:spcAft>
+                <a:spcPts val="0"/>
+              </a:spcAft>
+              <a:defRPr sz="850" b="1">
+                <a:solidFill>
+                  <a:srgbClr val="14213D"/>
+                </a:solidFill>
+                <a:latin typeface="Microsoft YaHei"/>
+              </a:defRPr>
+            </a:pPr>
+            <a:r>
+              <a:t>Action–Video</a:t>
+            </a:r>
+            <a:br/>
+            <a:r>
+              <a:t>联合策略生成</a:t>
+            </a:r>
+          </a:p>
+        </p:txBody>
+      </p:sp>
+      <p:sp>
+        <p:nvSpPr>
+          <p:cNvPr id="292" name="TextBox 291"/>
+          <p:cNvSpPr txBox="1"/>
+          <p:nvPr/>
+        </p:nvSpPr>
+        <p:spPr>
+          <a:xfrm>
+            <a:off x="9677400" y="5740400"/>
+            <a:ext cx="1866899" cy="444500"/>
+          </a:xfrm>
+          <a:prstGeom prst="rect">
+            <a:avLst/>
+          </a:prstGeom>
+          <a:noFill/>
+        </p:spPr>
+        <p:txBody>
+          <a:bodyPr wrap="none" lIns="0" rIns="0" tIns="0" bIns="0" anchor="ctr">
+            <a:spAutoFit/>
+          </a:bodyPr>
+          <a:lstStyle/>
+          <a:p>
+            <a:pPr algn="l">
+              <a:lnSpc>
+                <a:spcPct val="100000"/>
+              </a:lnSpc>
+              <a:spcAft>
+                <a:spcPts val="0"/>
+              </a:spcAft>
+              <a:defRPr sz="650" b="0">
+                <a:solidFill>
+                  <a:srgbClr val="5E6B82"/>
+                </a:solidFill>
+                <a:latin typeface="Microsoft YaHei"/>
+              </a:defRPr>
+            </a:pPr>
+            <a:r>
+              <a:t>同时预测动作及其视觉后果</a:t>
+            </a:r>
+            <a:br/>
+            <a:r>
+              <a:t>用 world-model 信号约束动作生成</a:t>
+            </a:r>
+          </a:p>
+        </p:txBody>
+      </p:sp>
+      <p:sp>
+        <p:nvSpPr>
+          <p:cNvPr id="293" name="TextBox 292"/>
+          <p:cNvSpPr txBox="1"/>
+          <p:nvPr/>
+        </p:nvSpPr>
+        <p:spPr>
+          <a:xfrm>
+            <a:off x="355600" y="6584950"/>
+            <a:ext cx="11480800" cy="139700"/>
+          </a:xfrm>
+          <a:prstGeom prst="rect">
+            <a:avLst/>
+          </a:prstGeom>
+          <a:noFill/>
+        </p:spPr>
+        <p:txBody>
+          <a:bodyPr wrap="none" lIns="0" rIns="0" tIns="0" bIns="0" anchor="t">
+            <a:spAutoFit/>
+          </a:bodyPr>
+          <a:lstStyle/>
+          <a:p>
+            <a:pPr algn="l">
+              <a:lnSpc>
+                <a:spcPct val="100000"/>
+              </a:lnSpc>
+              <a:spcAft>
+                <a:spcPts val="0"/>
+              </a:spcAft>
+              <a:defRPr sz="650" b="0">
+                <a:solidFill>
+                  <a:srgbClr val="5E6B82"/>
+                </a:solidFill>
+                <a:latin typeface="Microsoft YaHei"/>
+              </a:defRPr>
+            </a:pPr>
+            <a:r>
               <a:t>Sources: Cosmos 3 paper (arXiv:2606.02800v4) · NVIDIA Edge Policy model card · LingBot-VA paper/repo · local Edge/Nano profiling</a:t>
             </a:r>
           </a:p>
@@ -15467,7 +15508,7 @@
       </p:sp>
       <p:sp>
         <p:nvSpPr>
-          <p:cNvPr id="293" name="TextBox 292"/>
+          <p:cNvPr id="294" name="TextBox 293"/>
           <p:cNvSpPr txBox="1"/>
           <p:nvPr/>
         </p:nvSpPr>

</xml_diff>